<commit_message>
Open House post: remove top kicker line; v2 laptop plays a microscope video
Co-Authored-By: Claude Opus 5.5 <noreply@anthropic.com>
Claude-Session: https://claude.ai/code/session_01Rdc55TV8BuBqyKMSvWCEqP
</commit_message>
<xml_diff>
--- a/social/open-house-2026-10-16/open-house-oct16-editable.pptx
+++ b/social/open-house-2026-10-16/open-house-oct16-editable.pptx
@@ -1379,33 +1379,9 @@
           </a:prstGeom>
         </p:spPr>
       </p:pic>
-      <p:pic>
-        <p:nvPicPr>
-          <p:cNvPr id="23" name="kicker-rule" descr="kicker rule">    </p:cNvPr>
-          <p:cNvPicPr>
-            <a:picLocks noChangeAspect="1"/>
-          </p:cNvPicPr>
-          <p:nvPr/>
-        </p:nvPicPr>
-        <p:blipFill>
-          <a:blip r:embed="rId22"/>
-          <a:stretch>
-            <a:fillRect/>
-          </a:stretch>
-        </p:blipFill>
-        <p:spPr>
-          <a:xfrm>
-            <a:off x="592667" y="846667"/>
-            <a:ext cx="7967133" cy="16933"/>
-          </a:xfrm>
-          <a:prstGeom prst="rect">
-            <a:avLst/>
-          </a:prstGeom>
-        </p:spPr>
-      </p:pic>
       <p:sp>
         <p:nvSpPr>
-          <p:cNvPr id="24" name="date-pill"/>
+          <p:cNvPr id="23" name="date-pill"/>
           <p:cNvSpPr/>
           <p:nvPr/>
         </p:nvSpPr>
@@ -1432,7 +1408,7 @@
       </p:sp>
       <p:sp>
         <p:nvSpPr>
-          <p:cNvPr id="25" name="open-sign-text"/>
+          <p:cNvPr id="24" name="open-sign-text"/>
           <p:cNvSpPr txBox="1"/>
           <p:nvPr/>
         </p:nvSpPr>
@@ -1471,85 +1447,7 @@
       </p:sp>
       <p:sp>
         <p:nvSpPr>
-          <p:cNvPr id="26" name="kicker-left"/>
-          <p:cNvSpPr txBox="1"/>
-          <p:nvPr/>
-        </p:nvSpPr>
-        <p:spPr>
-          <a:xfrm>
-            <a:off x="592667" y="491067"/>
-            <a:ext cx="4402667" cy="287867"/>
-          </a:xfrm>
-          <a:prstGeom prst="rect">
-            <a:avLst/>
-          </a:prstGeom>
-          <a:noFill/>
-          <a:ln/>
-        </p:spPr>
-        <p:txBody>
-          <a:bodyPr wrap="none" lIns="0" tIns="0" rIns="0" bIns="0" rtlCol="0" anchor="t"/>
-          <a:lstStyle/>
-          <a:p>
-            <a:pPr algn="l" indent="0" marL="0">
-              <a:buNone/>
-            </a:pPr>
-            <a:r>
-              <a:rPr lang="en-US" sz="1400" b="1" dirty="0">
-                <a:solidFill>
-                  <a:srgbClr val="22371F"/>
-                </a:solidFill>
-                <a:latin typeface="Montserrat" pitchFamily="34" charset="0"/>
-                <a:ea typeface="Montserrat" pitchFamily="34" charset="-122"/>
-                <a:cs typeface="Montserrat" pitchFamily="34" charset="-120"/>
-              </a:rPr>
-              <a:t>SOIL FOOD WEB FOUNDATION</a:t>
-            </a:r>
-            <a:endParaRPr lang="en-US" sz="1400" dirty="0"/>
-          </a:p>
-        </p:txBody>
-      </p:sp>
-      <p:sp>
-        <p:nvSpPr>
-          <p:cNvPr id="27" name="kicker-right"/>
-          <p:cNvSpPr txBox="1"/>
-          <p:nvPr/>
-        </p:nvSpPr>
-        <p:spPr>
-          <a:xfrm>
-            <a:off x="6011333" y="491067"/>
-            <a:ext cx="2540000" cy="287867"/>
-          </a:xfrm>
-          <a:prstGeom prst="rect">
-            <a:avLst/>
-          </a:prstGeom>
-          <a:noFill/>
-          <a:ln/>
-        </p:spPr>
-        <p:txBody>
-          <a:bodyPr wrap="none" lIns="0" tIns="0" rIns="0" bIns="0" rtlCol="0" anchor="t"/>
-          <a:lstStyle/>
-          <a:p>
-            <a:pPr algn="r" indent="0" marL="0">
-              <a:buNone/>
-            </a:pPr>
-            <a:r>
-              <a:rPr lang="en-US" sz="1400" b="1" dirty="0">
-                <a:solidFill>
-                  <a:srgbClr val="22371F"/>
-                </a:solidFill>
-                <a:latin typeface="Montserrat" pitchFamily="34" charset="0"/>
-                <a:ea typeface="Montserrat" pitchFamily="34" charset="-122"/>
-                <a:cs typeface="Montserrat" pitchFamily="34" charset="-120"/>
-              </a:rPr>
-              <a:t>TURNING ONE</a:t>
-            </a:r>
-            <a:endParaRPr lang="en-US" sz="1400" dirty="0"/>
-          </a:p>
-        </p:txBody>
-      </p:sp>
-      <p:sp>
-        <p:nvSpPr>
-          <p:cNvPr id="28" name="headline"/>
+          <p:cNvPr id="25" name="headline"/>
           <p:cNvSpPr txBox="1"/>
           <p:nvPr/>
         </p:nvSpPr>
@@ -1588,7 +1486,7 @@
       </p:sp>
       <p:sp>
         <p:nvSpPr>
-          <p:cNvPr id="29" name="subline"/>
+          <p:cNvPr id="26" name="subline"/>
           <p:cNvSpPr txBox="1"/>
           <p:nvPr/>
         </p:nvSpPr>
@@ -1627,7 +1525,7 @@
       </p:sp>
       <p:sp>
         <p:nvSpPr>
-          <p:cNvPr id="30" name="date"/>
+          <p:cNvPr id="27" name="date"/>
           <p:cNvSpPr txBox="1"/>
           <p:nvPr/>
         </p:nvSpPr>

</xml_diff>